<commit_message>
updated pptx legend file for figure 1
</commit_message>
<xml_diff>
--- a/plottingCode/Fig1_schematic/formation_channels_legend.pptx
+++ b/plottingCode/Fig1_schematic/formation_channels_legend.pptx
@@ -212,7 +212,7 @@
           <a:p>
             <a:fld id="{BDAC1B45-61CC-B64D-BCEF-949BE053BD15}" type="datetimeFigureOut">
               <a:rPr lang="en-US" smtClean="0"/>
-              <a:t>2/10/26</a:t>
+              <a:t>4/20/26</a:t>
             </a:fld>
             <a:endParaRPr lang="en-US"/>
           </a:p>
@@ -1126,7 +1126,7 @@
           <a:p>
             <a:fld id="{DA65CD7A-DB9E-E745-8EE8-D0AEE8EA9938}" type="datetimeFigureOut">
               <a:rPr lang="en-US" smtClean="0"/>
-              <a:t>2/10/26</a:t>
+              <a:t>4/20/26</a:t>
             </a:fld>
             <a:endParaRPr lang="en-US"/>
           </a:p>
@@ -1296,7 +1296,7 @@
           <a:p>
             <a:fld id="{DA65CD7A-DB9E-E745-8EE8-D0AEE8EA9938}" type="datetimeFigureOut">
               <a:rPr lang="en-US" smtClean="0"/>
-              <a:t>2/10/26</a:t>
+              <a:t>4/20/26</a:t>
             </a:fld>
             <a:endParaRPr lang="en-US"/>
           </a:p>
@@ -1476,7 +1476,7 @@
           <a:p>
             <a:fld id="{DA65CD7A-DB9E-E745-8EE8-D0AEE8EA9938}" type="datetimeFigureOut">
               <a:rPr lang="en-US" smtClean="0"/>
-              <a:t>2/10/26</a:t>
+              <a:t>4/20/26</a:t>
             </a:fld>
             <a:endParaRPr lang="en-US"/>
           </a:p>
@@ -1646,7 +1646,7 @@
           <a:p>
             <a:fld id="{DA65CD7A-DB9E-E745-8EE8-D0AEE8EA9938}" type="datetimeFigureOut">
               <a:rPr lang="en-US" smtClean="0"/>
-              <a:t>2/10/26</a:t>
+              <a:t>4/20/26</a:t>
             </a:fld>
             <a:endParaRPr lang="en-US"/>
           </a:p>
@@ -1892,7 +1892,7 @@
           <a:p>
             <a:fld id="{DA65CD7A-DB9E-E745-8EE8-D0AEE8EA9938}" type="datetimeFigureOut">
               <a:rPr lang="en-US" smtClean="0"/>
-              <a:t>2/10/26</a:t>
+              <a:t>4/20/26</a:t>
             </a:fld>
             <a:endParaRPr lang="en-US"/>
           </a:p>
@@ -2124,7 +2124,7 @@
           <a:p>
             <a:fld id="{DA65CD7A-DB9E-E745-8EE8-D0AEE8EA9938}" type="datetimeFigureOut">
               <a:rPr lang="en-US" smtClean="0"/>
-              <a:t>2/10/26</a:t>
+              <a:t>4/20/26</a:t>
             </a:fld>
             <a:endParaRPr lang="en-US"/>
           </a:p>
@@ -2491,7 +2491,7 @@
           <a:p>
             <a:fld id="{DA65CD7A-DB9E-E745-8EE8-D0AEE8EA9938}" type="datetimeFigureOut">
               <a:rPr lang="en-US" smtClean="0"/>
-              <a:t>2/10/26</a:t>
+              <a:t>4/20/26</a:t>
             </a:fld>
             <a:endParaRPr lang="en-US"/>
           </a:p>
@@ -2609,7 +2609,7 @@
           <a:p>
             <a:fld id="{DA65CD7A-DB9E-E745-8EE8-D0AEE8EA9938}" type="datetimeFigureOut">
               <a:rPr lang="en-US" smtClean="0"/>
-              <a:t>2/10/26</a:t>
+              <a:t>4/20/26</a:t>
             </a:fld>
             <a:endParaRPr lang="en-US"/>
           </a:p>
@@ -2704,7 +2704,7 @@
           <a:p>
             <a:fld id="{DA65CD7A-DB9E-E745-8EE8-D0AEE8EA9938}" type="datetimeFigureOut">
               <a:rPr lang="en-US" smtClean="0"/>
-              <a:t>2/10/26</a:t>
+              <a:t>4/20/26</a:t>
             </a:fld>
             <a:endParaRPr lang="en-US"/>
           </a:p>
@@ -2981,7 +2981,7 @@
           <a:p>
             <a:fld id="{DA65CD7A-DB9E-E745-8EE8-D0AEE8EA9938}" type="datetimeFigureOut">
               <a:rPr lang="en-US" smtClean="0"/>
-              <a:t>2/10/26</a:t>
+              <a:t>4/20/26</a:t>
             </a:fld>
             <a:endParaRPr lang="en-US"/>
           </a:p>
@@ -3238,7 +3238,7 @@
           <a:p>
             <a:fld id="{DA65CD7A-DB9E-E745-8EE8-D0AEE8EA9938}" type="datetimeFigureOut">
               <a:rPr lang="en-US" smtClean="0"/>
-              <a:t>2/10/26</a:t>
+              <a:t>4/20/26</a:t>
             </a:fld>
             <a:endParaRPr lang="en-US"/>
           </a:p>
@@ -3451,7 +3451,7 @@
           <a:p>
             <a:fld id="{DA65CD7A-DB9E-E745-8EE8-D0AEE8EA9938}" type="datetimeFigureOut">
               <a:rPr lang="en-US" smtClean="0"/>
-              <a:t>2/10/26</a:t>
+              <a:t>4/20/26</a:t>
             </a:fld>
             <a:endParaRPr lang="en-US"/>
           </a:p>
@@ -25848,7 +25848,7 @@
           </p:nvSpPr>
           <p:spPr>
             <a:xfrm>
-              <a:off x="882158" y="2107238"/>
+              <a:off x="882160" y="2107238"/>
               <a:ext cx="2835841" cy="369332"/>
             </a:xfrm>
             <a:prstGeom prst="rect">
@@ -26194,7 +26194,7 @@
               <a:pPr algn="ctr"/>
               <a:r>
                 <a:rPr lang="en-US" dirty="0"/>
-                <a:t>classic OSMT</a:t>
+                <a:t>classic SMT</a:t>
               </a:r>
               <a:br>
                 <a:rPr lang="en-US" dirty="0"/>
@@ -26815,7 +26815,7 @@
               <a:pPr algn="ctr"/>
               <a:r>
                 <a:rPr lang="en-US" dirty="0"/>
-                <a:t>(SMT+CEE)</a:t>
+                <a:t>(SMT+CE)</a:t>
               </a:r>
             </a:p>
           </p:txBody>

</xml_diff>